<commit_message>
Add Fatorial and SelectionSort classes with iterative and recursive factorial methods, and selection sort implementation
</commit_message>
<xml_diff>
--- a/Slides/04-Selection-Sort.pptx
+++ b/Slides/04-Selection-Sort.pptx
@@ -304,7 +304,7 @@
           <a:p>
             <a:fld id="{A061563A-35C7-49EE-9FEB-8EB53781E0B1}" type="datetimeFigureOut">
               <a:rPr lang="pt-BR" smtClean="0"/>
-              <a:t>07/02/2026</a:t>
+              <a:t>29/08/2026</a:t>
             </a:fld>
             <a:endParaRPr lang="pt-BR" dirty="0"/>
           </a:p>
@@ -472,7 +472,7 @@
           <a:p>
             <a:fld id="{A061563A-35C7-49EE-9FEB-8EB53781E0B1}" type="datetimeFigureOut">
               <a:rPr lang="pt-BR" smtClean="0"/>
-              <a:t>07/02/2026</a:t>
+              <a:t>29/08/2026</a:t>
             </a:fld>
             <a:endParaRPr lang="pt-BR" dirty="0"/>
           </a:p>
@@ -650,7 +650,7 @@
           <a:p>
             <a:fld id="{A061563A-35C7-49EE-9FEB-8EB53781E0B1}" type="datetimeFigureOut">
               <a:rPr lang="pt-BR" smtClean="0"/>
-              <a:t>07/02/2026</a:t>
+              <a:t>29/08/2026</a:t>
             </a:fld>
             <a:endParaRPr lang="pt-BR" dirty="0"/>
           </a:p>
@@ -818,7 +818,7 @@
           <a:p>
             <a:fld id="{A061563A-35C7-49EE-9FEB-8EB53781E0B1}" type="datetimeFigureOut">
               <a:rPr lang="pt-BR" smtClean="0"/>
-              <a:t>07/02/2026</a:t>
+              <a:t>29/08/2026</a:t>
             </a:fld>
             <a:endParaRPr lang="pt-BR" dirty="0"/>
           </a:p>
@@ -1063,7 +1063,7 @@
           <a:p>
             <a:fld id="{A061563A-35C7-49EE-9FEB-8EB53781E0B1}" type="datetimeFigureOut">
               <a:rPr lang="pt-BR" smtClean="0"/>
-              <a:t>07/02/2026</a:t>
+              <a:t>29/08/2026</a:t>
             </a:fld>
             <a:endParaRPr lang="pt-BR" dirty="0"/>
           </a:p>
@@ -1348,7 +1348,7 @@
           <a:p>
             <a:fld id="{A061563A-35C7-49EE-9FEB-8EB53781E0B1}" type="datetimeFigureOut">
               <a:rPr lang="pt-BR" smtClean="0"/>
-              <a:t>07/02/2026</a:t>
+              <a:t>29/08/2026</a:t>
             </a:fld>
             <a:endParaRPr lang="pt-BR" dirty="0"/>
           </a:p>
@@ -1767,7 +1767,7 @@
           <a:p>
             <a:fld id="{A061563A-35C7-49EE-9FEB-8EB53781E0B1}" type="datetimeFigureOut">
               <a:rPr lang="pt-BR" smtClean="0"/>
-              <a:t>07/02/2026</a:t>
+              <a:t>29/08/2026</a:t>
             </a:fld>
             <a:endParaRPr lang="pt-BR" dirty="0"/>
           </a:p>
@@ -1884,7 +1884,7 @@
           <a:p>
             <a:fld id="{A061563A-35C7-49EE-9FEB-8EB53781E0B1}" type="datetimeFigureOut">
               <a:rPr lang="pt-BR" smtClean="0"/>
-              <a:t>07/02/2026</a:t>
+              <a:t>29/08/2026</a:t>
             </a:fld>
             <a:endParaRPr lang="pt-BR" dirty="0"/>
           </a:p>
@@ -1979,7 +1979,7 @@
           <a:p>
             <a:fld id="{A061563A-35C7-49EE-9FEB-8EB53781E0B1}" type="datetimeFigureOut">
               <a:rPr lang="pt-BR" smtClean="0"/>
-              <a:t>07/02/2026</a:t>
+              <a:t>29/08/2026</a:t>
             </a:fld>
             <a:endParaRPr lang="pt-BR" dirty="0"/>
           </a:p>
@@ -2254,7 +2254,7 @@
           <a:p>
             <a:fld id="{A061563A-35C7-49EE-9FEB-8EB53781E0B1}" type="datetimeFigureOut">
               <a:rPr lang="pt-BR" smtClean="0"/>
-              <a:t>07/02/2026</a:t>
+              <a:t>29/08/2026</a:t>
             </a:fld>
             <a:endParaRPr lang="pt-BR" dirty="0"/>
           </a:p>
@@ -2506,7 +2506,7 @@
           <a:p>
             <a:fld id="{A061563A-35C7-49EE-9FEB-8EB53781E0B1}" type="datetimeFigureOut">
               <a:rPr lang="pt-BR" smtClean="0"/>
-              <a:t>07/02/2026</a:t>
+              <a:t>29/08/2026</a:t>
             </a:fld>
             <a:endParaRPr lang="pt-BR" dirty="0"/>
           </a:p>
@@ -2720,7 +2720,7 @@
           <a:p>
             <a:fld id="{A061563A-35C7-49EE-9FEB-8EB53781E0B1}" type="datetimeFigureOut">
               <a:rPr lang="pt-BR" smtClean="0"/>
-              <a:t>07/02/2026</a:t>
+              <a:t>29/08/2026</a:t>
             </a:fld>
             <a:endParaRPr lang="pt-BR" dirty="0"/>
           </a:p>
@@ -3449,7 +3449,7 @@
                   <a:srgbClr val="00B050"/>
                 </a:solidFill>
               </a:rPr>
-              <a:t>251</a:t>
+              <a:t>09</a:t>
             </a:r>
             <a:r>
               <a:rPr lang="pt-BR" sz="2000" dirty="0">
@@ -3457,7 +3457,7 @@
                   <a:srgbClr val="7030A0"/>
                 </a:solidFill>
               </a:rPr>
-              <a:t>@fatec.</a:t>
+              <a:t>@cps.</a:t>
             </a:r>
             <a:r>
               <a:rPr lang="pt-BR" sz="2000" dirty="0">

</xml_diff>